<commit_message>
talk: 감사합니다 on the closing slide
The closing slide carries 감사합니다 (thank you, formal) beside "Collaborate", in
Malgun Gothic with Apple SD Gothic Neo and Noto Sans KR as fallbacks, since the
Instrument fonts have no Hangul; the notes give the pronunciation. Decks, PDF, preview
and outline rebuilt.

Co-Authored-By: Claude Opus 5.5 (1M context) <noreply@anthropic.com>
</commit_message>
<xml_diff>
--- a/talk/deck/congress/Fridman_WSC2026_open_science_v8.pptx
+++ b/talk/deck/congress/Fridman_WSC2026_open_science_v8.pptx
@@ -1149,7 +1149,7 @@
           <a:lstStyle/>
           <a:p>
             <a:r>
-              <a:t>Say, do not show: we measured ourselves; the numbers are not flattering, but they can improve. One line, then stop. Leave the links and the QR codes up during questions. Thank the session chairs.</a:t>
+              <a:t>Say, do not show: we measured ourselves; the numbers are not flattering, but they can improve. One line, then stop. Leave the links and the QR codes up during questions. Thank the session chairs. Close with 감사합니다, gam-sa-ham-ni-da (thank you, formal).</a:t>
             </a:r>
           </a:p>
         </p:txBody>
@@ -11609,7 +11609,7 @@
         <p:spPr>
           <a:xfrm>
             <a:off x="609600" y="609600"/>
-            <a:ext cx="7962900" cy="598140"/>
+            <a:ext cx="3081263" cy="598140"/>
           </a:xfrm>
           <a:prstGeom prst="rect">
             <a:avLst/>
@@ -11658,6 +11658,56 @@
         </p:nvSpPr>
         <p:spPr>
           <a:xfrm>
+            <a:off x="6439793" y="733425"/>
+            <a:ext cx="2132707" cy="489570"/>
+          </a:xfrm>
+          <a:prstGeom prst="rect">
+            <a:avLst/>
+          </a:prstGeom>
+          <a:noFill/>
+          <a:ln>
+            <a:noFill/>
+          </a:ln>
+        </p:spPr>
+        <p:txBody>
+          <a:bodyPr wrap="none" lIns="0" rIns="0" tIns="0" bIns="0" anchor="t"/>
+          <a:lstStyle/>
+          <a:p>
+            <a:pPr algn="l">
+              <a:lnSpc>
+                <a:spcPts val="3705"/>
+              </a:lnSpc>
+              <a:spcBef>
+                <a:spcPts val="0"/>
+              </a:spcBef>
+              <a:spcAft>
+                <a:spcPts val="0"/>
+              </a:spcAft>
+              <a:buNone/>
+            </a:pPr>
+            <a:r>
+              <a:rPr lang="en-US" sz="3900" b="0" i="0" spc="-75">
+                <a:solidFill>
+                  <a:srgbClr val="E8475B"/>
+                </a:solidFill>
+                <a:latin typeface="Malgun Gothic"/>
+                <a:ea typeface="Malgun Gothic"/>
+                <a:cs typeface="Malgun Gothic"/>
+              </a:rPr>
+              <a:t xml:space="preserve">감사합니다</a:t>
+            </a:r>
+            <a:endParaRPr lang="en-US"/>
+          </a:p>
+        </p:txBody>
+      </p:sp>
+      <p:sp>
+        <p:nvSpPr>
+          <p:cNvPr id="10" name="Text 10"/>
+          <p:cNvSpPr txBox="1"/>
+          <p:nvPr/>
+        </p:nvSpPr>
+        <p:spPr>
+          <a:xfrm>
             <a:off x="1638300" y="3367311"/>
             <a:ext cx="1548482" cy="323850"/>
           </a:xfrm>
@@ -11702,7 +11752,7 @@
       </p:sp>
       <p:sp>
         <p:nvSpPr>
-          <p:cNvPr id="10" name="Text 10"/>
+          <p:cNvPr id="11" name="Text 11"/>
           <p:cNvSpPr txBox="1"/>
           <p:nvPr/>
         </p:nvSpPr>
@@ -11764,7 +11814,7 @@
       </p:sp>
       <p:sp>
         <p:nvSpPr>
-          <p:cNvPr id="11" name="Text 11"/>
+          <p:cNvPr id="12" name="Text 12"/>
           <p:cNvSpPr txBox="1"/>
           <p:nvPr/>
         </p:nvSpPr>
@@ -11814,7 +11864,7 @@
       </p:sp>
       <p:sp>
         <p:nvSpPr>
-          <p:cNvPr id="12" name="Text 12"/>
+          <p:cNvPr id="13" name="Text 13"/>
           <p:cNvSpPr txBox="1"/>
           <p:nvPr/>
         </p:nvSpPr>
@@ -11864,7 +11914,7 @@
       </p:sp>
       <p:sp>
         <p:nvSpPr>
-          <p:cNvPr id="13" name="Text 13"/>
+          <p:cNvPr id="14" name="Text 14"/>
           <p:cNvSpPr txBox="1"/>
           <p:nvPr/>
         </p:nvSpPr>
@@ -11926,7 +11976,7 @@
       </p:sp>
       <p:sp>
         <p:nvSpPr>
-          <p:cNvPr id="14" name="Text 14"/>
+          <p:cNvPr id="15" name="Text 15"/>
           <p:cNvSpPr txBox="1"/>
           <p:nvPr/>
         </p:nvSpPr>
@@ -11976,7 +12026,7 @@
       </p:sp>
       <p:sp>
         <p:nvSpPr>
-          <p:cNvPr id="15" name="Text 15"/>
+          <p:cNvPr id="16" name="Text 16"/>
           <p:cNvSpPr txBox="1"/>
           <p:nvPr/>
         </p:nvSpPr>
@@ -12026,7 +12076,7 @@
       </p:sp>
       <p:sp>
         <p:nvSpPr>
-          <p:cNvPr id="16" name="Text 16"/>
+          <p:cNvPr id="17" name="Text 17"/>
           <p:cNvSpPr txBox="1"/>
           <p:nvPr/>
         </p:nvSpPr>
@@ -12076,7 +12126,7 @@
       </p:sp>
       <p:sp>
         <p:nvSpPr>
-          <p:cNvPr id="17" name="Text 17"/>
+          <p:cNvPr id="18" name="Text 18"/>
           <p:cNvSpPr txBox="1"/>
           <p:nvPr/>
         </p:nvSpPr>
@@ -12126,7 +12176,7 @@
       </p:sp>
       <p:sp>
         <p:nvSpPr>
-          <p:cNvPr id="18" name="Text 18"/>
+          <p:cNvPr id="19" name="Text 19"/>
           <p:cNvSpPr txBox="1"/>
           <p:nvPr/>
         </p:nvSpPr>
@@ -12176,7 +12226,7 @@
       </p:sp>
       <p:sp>
         <p:nvSpPr>
-          <p:cNvPr id="19" name="Text 19"/>
+          <p:cNvPr id="20" name="Text 20"/>
           <p:cNvSpPr txBox="1"/>
           <p:nvPr/>
         </p:nvSpPr>

</xml_diff>